<commit_message>
Deployed 9c318d9 with MkDocs version: 1.5.3
</commit_message>
<xml_diff>
--- a/assets/apresentacao.pptx
+++ b/assets/apresentacao.pptx
@@ -7340,2026 +7340,6 @@
       </p:sp>
       <p:sp>
         <p:nvSpPr>
-          <p:cNvPr id="7" name="Shape 5"/>
-          <p:cNvSpPr/>
-          <p:nvPr/>
-        </p:nvSpPr>
-        <p:spPr>
-          <a:xfrm>
-            <a:off x="731520" y="2103120"/>
-            <a:ext cx="2057400" cy="1243584"/>
-          </a:xfrm>
-          <a:prstGeom prst="rect">
-            <a:avLst/>
-          </a:prstGeom>
-          <a:solidFill>
-            <a:srgbClr val="FFFFFF"/>
-          </a:solidFill>
-          <a:ln w="12700">
-            <a:solidFill>
-              <a:srgbClr val="1B1E24"/>
-            </a:solidFill>
-            <a:prstDash val="solid"/>
-          </a:ln>
-        </p:spPr>
-      </p:sp>
-      <p:sp>
-        <p:nvSpPr>
-          <p:cNvPr id="8" name="Text 6"/>
-          <p:cNvSpPr/>
-          <p:nvPr/>
-        </p:nvSpPr>
-        <p:spPr>
-          <a:xfrm>
-            <a:off x="731520" y="2103120"/>
-            <a:ext cx="2057400" cy="402336"/>
-          </a:xfrm>
-          <a:prstGeom prst="rect">
-            <a:avLst/>
-          </a:prstGeom>
-          <a:noFill/>
-          <a:ln/>
-        </p:spPr>
-        <p:txBody>
-          <a:bodyPr wrap="square" lIns="0" tIns="0" rIns="0" bIns="0" rtlCol="0" anchor="ctr"/>
-          <a:lstStyle/>
-          <a:p>
-            <a:pPr algn="ctr" indent="0" marL="0">
-              <a:lnSpc>
-                <a:spcPct val="100000"/>
-              </a:lnSpc>
-              <a:buNone/>
-            </a:pPr>
-            <a:r>
-              <a:rPr lang="en-US" sz="1250" b="1" dirty="0">
-                <a:solidFill>
-                  <a:srgbClr val="1B1E24"/>
-                </a:solidFill>
-                <a:latin typeface="Calibri" pitchFamily="34" charset="0"/>
-                <a:ea typeface="Calibri" pitchFamily="34" charset="-122"/>
-                <a:cs typeface="Calibri" pitchFamily="34" charset="-120"/>
-              </a:rPr>
-              <a:t>Aluno</a:t>
-            </a:r>
-            <a:endParaRPr lang="en-US" sz="1250" dirty="0"/>
-          </a:p>
-        </p:txBody>
-      </p:sp>
-      <p:sp>
-        <p:nvSpPr>
-          <p:cNvPr id="9" name="Shape 7"/>
-          <p:cNvSpPr/>
-          <p:nvPr/>
-        </p:nvSpPr>
-        <p:spPr>
-          <a:xfrm>
-            <a:off x="731520" y="2505456"/>
-            <a:ext cx="2057400" cy="0"/>
-          </a:xfrm>
-          <a:prstGeom prst="line">
-            <a:avLst/>
-          </a:prstGeom>
-          <a:noFill/>
-          <a:ln w="9525">
-            <a:solidFill>
-              <a:srgbClr val="1B1E24"/>
-            </a:solidFill>
-            <a:prstDash val="solid"/>
-          </a:ln>
-        </p:spPr>
-      </p:sp>
-      <p:sp>
-        <p:nvSpPr>
-          <p:cNvPr id="10" name="Text 8"/>
-          <p:cNvSpPr/>
-          <p:nvPr/>
-        </p:nvSpPr>
-        <p:spPr>
-          <a:xfrm>
-            <a:off x="859536" y="2532888"/>
-            <a:ext cx="1874520" cy="713232"/>
-          </a:xfrm>
-          <a:prstGeom prst="rect">
-            <a:avLst/>
-          </a:prstGeom>
-          <a:noFill/>
-          <a:ln/>
-        </p:spPr>
-        <p:txBody>
-          <a:bodyPr wrap="square" lIns="0" tIns="0" rIns="0" bIns="0" rtlCol="0" anchor="t"/>
-          <a:lstStyle/>
-          <a:p>
-            <a:pPr algn="l" indent="0" marL="0">
-              <a:lnSpc>
-                <a:spcPts val="1872"/>
-              </a:lnSpc>
-              <a:buNone/>
-            </a:pPr>
-            <a:r>
-              <a:rPr lang="en-US" sz="1100" dirty="0">
-                <a:solidFill>
-                  <a:srgbClr val="5B6068"/>
-                </a:solidFill>
-                <a:latin typeface="Calibri" pitchFamily="34" charset="0"/>
-                <a:ea typeface="Calibri" pitchFamily="34" charset="-122"/>
-                <a:cs typeface="Calibri" pitchFamily="34" charset="-120"/>
-              </a:rPr>
-              <a:t>+ nome</a:t>
-            </a:r>
-            <a:endParaRPr lang="en-US" sz="1100" dirty="0"/>
-          </a:p>
-          <a:p>
-            <a:pPr algn="l" indent="0" marL="0">
-              <a:lnSpc>
-                <a:spcPts val="1872"/>
-              </a:lnSpc>
-              <a:buNone/>
-            </a:pPr>
-            <a:r>
-              <a:rPr lang="en-US" sz="1100" dirty="0">
-                <a:solidFill>
-                  <a:srgbClr val="5B6068"/>
-                </a:solidFill>
-                <a:latin typeface="Calibri" pitchFamily="34" charset="0"/>
-                <a:ea typeface="Calibri" pitchFamily="34" charset="-122"/>
-                <a:cs typeface="Calibri" pitchFamily="34" charset="-120"/>
-              </a:rPr>
-              <a:t>+ email</a:t>
-            </a:r>
-            <a:endParaRPr lang="en-US" sz="1100" dirty="0"/>
-          </a:p>
-          <a:p>
-            <a:pPr algn="l" indent="0" marL="0">
-              <a:lnSpc>
-                <a:spcPts val="1872"/>
-              </a:lnSpc>
-              <a:buNone/>
-            </a:pPr>
-            <a:r>
-              <a:rPr lang="en-US" sz="1100" dirty="0">
-                <a:solidFill>
-                  <a:srgbClr val="5B6068"/>
-                </a:solidFill>
-                <a:latin typeface="Calibri" pitchFamily="34" charset="0"/>
-                <a:ea typeface="Calibri" pitchFamily="34" charset="-122"/>
-                <a:cs typeface="Calibri" pitchFamily="34" charset="-120"/>
-              </a:rPr>
-              <a:t>+ dataCadastro</a:t>
-            </a:r>
-            <a:endParaRPr lang="en-US" sz="1100" dirty="0"/>
-          </a:p>
-        </p:txBody>
-      </p:sp>
-      <p:sp>
-        <p:nvSpPr>
-          <p:cNvPr id="11" name="Shape 9"/>
-          <p:cNvSpPr/>
-          <p:nvPr/>
-        </p:nvSpPr>
-        <p:spPr>
-          <a:xfrm>
-            <a:off x="3611880" y="2103120"/>
-            <a:ext cx="2057400" cy="1005840"/>
-          </a:xfrm>
-          <a:prstGeom prst="rect">
-            <a:avLst/>
-          </a:prstGeom>
-          <a:solidFill>
-            <a:srgbClr val="FFFFFF"/>
-          </a:solidFill>
-          <a:ln w="12700">
-            <a:solidFill>
-              <a:srgbClr val="1B1E24"/>
-            </a:solidFill>
-            <a:prstDash val="solid"/>
-          </a:ln>
-        </p:spPr>
-      </p:sp>
-      <p:sp>
-        <p:nvSpPr>
-          <p:cNvPr id="12" name="Text 10"/>
-          <p:cNvSpPr/>
-          <p:nvPr/>
-        </p:nvSpPr>
-        <p:spPr>
-          <a:xfrm>
-            <a:off x="3611880" y="2103120"/>
-            <a:ext cx="2057400" cy="402336"/>
-          </a:xfrm>
-          <a:prstGeom prst="rect">
-            <a:avLst/>
-          </a:prstGeom>
-          <a:noFill/>
-          <a:ln/>
-        </p:spPr>
-        <p:txBody>
-          <a:bodyPr wrap="square" lIns="0" tIns="0" rIns="0" bIns="0" rtlCol="0" anchor="ctr"/>
-          <a:lstStyle/>
-          <a:p>
-            <a:pPr algn="ctr" indent="0" marL="0">
-              <a:lnSpc>
-                <a:spcPct val="100000"/>
-              </a:lnSpc>
-              <a:buNone/>
-            </a:pPr>
-            <a:r>
-              <a:rPr lang="en-US" sz="1250" b="1" dirty="0">
-                <a:solidFill>
-                  <a:srgbClr val="1B1E24"/>
-                </a:solidFill>
-                <a:latin typeface="Calibri" pitchFamily="34" charset="0"/>
-                <a:ea typeface="Calibri" pitchFamily="34" charset="-122"/>
-                <a:cs typeface="Calibri" pitchFamily="34" charset="-120"/>
-              </a:rPr>
-              <a:t>Submissao</a:t>
-            </a:r>
-            <a:endParaRPr lang="en-US" sz="1250" dirty="0"/>
-          </a:p>
-        </p:txBody>
-      </p:sp>
-      <p:sp>
-        <p:nvSpPr>
-          <p:cNvPr id="13" name="Shape 11"/>
-          <p:cNvSpPr/>
-          <p:nvPr/>
-        </p:nvSpPr>
-        <p:spPr>
-          <a:xfrm>
-            <a:off x="3611880" y="2505456"/>
-            <a:ext cx="2057400" cy="0"/>
-          </a:xfrm>
-          <a:prstGeom prst="line">
-            <a:avLst/>
-          </a:prstGeom>
-          <a:noFill/>
-          <a:ln w="9525">
-            <a:solidFill>
-              <a:srgbClr val="1B1E24"/>
-            </a:solidFill>
-            <a:prstDash val="solid"/>
-          </a:ln>
-        </p:spPr>
-      </p:sp>
-      <p:sp>
-        <p:nvSpPr>
-          <p:cNvPr id="14" name="Text 12"/>
-          <p:cNvSpPr/>
-          <p:nvPr/>
-        </p:nvSpPr>
-        <p:spPr>
-          <a:xfrm>
-            <a:off x="3739896" y="2532888"/>
-            <a:ext cx="1874520" cy="475488"/>
-          </a:xfrm>
-          <a:prstGeom prst="rect">
-            <a:avLst/>
-          </a:prstGeom>
-          <a:noFill/>
-          <a:ln/>
-        </p:spPr>
-        <p:txBody>
-          <a:bodyPr wrap="square" lIns="0" tIns="0" rIns="0" bIns="0" rtlCol="0" anchor="t"/>
-          <a:lstStyle/>
-          <a:p>
-            <a:pPr algn="l" indent="0" marL="0">
-              <a:lnSpc>
-                <a:spcPts val="1872"/>
-              </a:lnSpc>
-              <a:buNone/>
-            </a:pPr>
-            <a:r>
-              <a:rPr lang="en-US" sz="1100" dirty="0">
-                <a:solidFill>
-                  <a:srgbClr val="5B6068"/>
-                </a:solidFill>
-                <a:latin typeface="Calibri" pitchFamily="34" charset="0"/>
-                <a:ea typeface="Calibri" pitchFamily="34" charset="-122"/>
-                <a:cs typeface="Calibri" pitchFamily="34" charset="-120"/>
-              </a:rPr>
-              <a:t>+ dataEnvio</a:t>
-            </a:r>
-            <a:endParaRPr lang="en-US" sz="1100" dirty="0"/>
-          </a:p>
-          <a:p>
-            <a:pPr algn="l" indent="0" marL="0">
-              <a:lnSpc>
-                <a:spcPts val="1872"/>
-              </a:lnSpc>
-              <a:buNone/>
-            </a:pPr>
-            <a:r>
-              <a:rPr lang="en-US" sz="1100" dirty="0">
-                <a:solidFill>
-                  <a:srgbClr val="5B6068"/>
-                </a:solidFill>
-                <a:latin typeface="Calibri" pitchFamily="34" charset="0"/>
-                <a:ea typeface="Calibri" pitchFamily="34" charset="-122"/>
-                <a:cs typeface="Calibri" pitchFamily="34" charset="-120"/>
-              </a:rPr>
-              <a:t>+ status</a:t>
-            </a:r>
-            <a:endParaRPr lang="en-US" sz="1100" dirty="0"/>
-          </a:p>
-        </p:txBody>
-      </p:sp>
-      <p:sp>
-        <p:nvSpPr>
-          <p:cNvPr id="15" name="Shape 13"/>
-          <p:cNvSpPr/>
-          <p:nvPr/>
-        </p:nvSpPr>
-        <p:spPr>
-          <a:xfrm>
-            <a:off x="6492240" y="2103120"/>
-            <a:ext cx="2057400" cy="1005840"/>
-          </a:xfrm>
-          <a:prstGeom prst="rect">
-            <a:avLst/>
-          </a:prstGeom>
-          <a:solidFill>
-            <a:srgbClr val="FFFFFF"/>
-          </a:solidFill>
-          <a:ln w="12700">
-            <a:solidFill>
-              <a:srgbClr val="1B1E24"/>
-            </a:solidFill>
-            <a:prstDash val="solid"/>
-          </a:ln>
-        </p:spPr>
-      </p:sp>
-      <p:sp>
-        <p:nvSpPr>
-          <p:cNvPr id="16" name="Text 14"/>
-          <p:cNvSpPr/>
-          <p:nvPr/>
-        </p:nvSpPr>
-        <p:spPr>
-          <a:xfrm>
-            <a:off x="6492240" y="2103120"/>
-            <a:ext cx="2057400" cy="402336"/>
-          </a:xfrm>
-          <a:prstGeom prst="rect">
-            <a:avLst/>
-          </a:prstGeom>
-          <a:noFill/>
-          <a:ln/>
-        </p:spPr>
-        <p:txBody>
-          <a:bodyPr wrap="square" lIns="0" tIns="0" rIns="0" bIns="0" rtlCol="0" anchor="ctr"/>
-          <a:lstStyle/>
-          <a:p>
-            <a:pPr algn="ctr" indent="0" marL="0">
-              <a:lnSpc>
-                <a:spcPct val="100000"/>
-              </a:lnSpc>
-              <a:buNone/>
-            </a:pPr>
-            <a:r>
-              <a:rPr lang="en-US" sz="1250" b="1" dirty="0">
-                <a:solidFill>
-                  <a:srgbClr val="1B1E24"/>
-                </a:solidFill>
-                <a:latin typeface="Calibri" pitchFamily="34" charset="0"/>
-                <a:ea typeface="Calibri" pitchFamily="34" charset="-122"/>
-                <a:cs typeface="Calibri" pitchFamily="34" charset="-120"/>
-              </a:rPr>
-              <a:t>RespostaInformada</a:t>
-            </a:r>
-            <a:endParaRPr lang="en-US" sz="1250" dirty="0"/>
-          </a:p>
-        </p:txBody>
-      </p:sp>
-      <p:sp>
-        <p:nvSpPr>
-          <p:cNvPr id="17" name="Shape 15"/>
-          <p:cNvSpPr/>
-          <p:nvPr/>
-        </p:nvSpPr>
-        <p:spPr>
-          <a:xfrm>
-            <a:off x="6492240" y="2505456"/>
-            <a:ext cx="2057400" cy="0"/>
-          </a:xfrm>
-          <a:prstGeom prst="line">
-            <a:avLst/>
-          </a:prstGeom>
-          <a:noFill/>
-          <a:ln w="9525">
-            <a:solidFill>
-              <a:srgbClr val="1B1E24"/>
-            </a:solidFill>
-            <a:prstDash val="solid"/>
-          </a:ln>
-        </p:spPr>
-      </p:sp>
-      <p:sp>
-        <p:nvSpPr>
-          <p:cNvPr id="18" name="Text 16"/>
-          <p:cNvSpPr/>
-          <p:nvPr/>
-        </p:nvSpPr>
-        <p:spPr>
-          <a:xfrm>
-            <a:off x="6620256" y="2532888"/>
-            <a:ext cx="1874520" cy="475488"/>
-          </a:xfrm>
-          <a:prstGeom prst="rect">
-            <a:avLst/>
-          </a:prstGeom>
-          <a:noFill/>
-          <a:ln/>
-        </p:spPr>
-        <p:txBody>
-          <a:bodyPr wrap="square" lIns="0" tIns="0" rIns="0" bIns="0" rtlCol="0" anchor="t"/>
-          <a:lstStyle/>
-          <a:p>
-            <a:pPr algn="l" indent="0" marL="0">
-              <a:lnSpc>
-                <a:spcPts val="1872"/>
-              </a:lnSpc>
-              <a:buNone/>
-            </a:pPr>
-            <a:r>
-              <a:rPr lang="en-US" sz="1100" dirty="0">
-                <a:solidFill>
-                  <a:srgbClr val="5B6068"/>
-                </a:solidFill>
-                <a:latin typeface="Calibri" pitchFamily="34" charset="0"/>
-                <a:ea typeface="Calibri" pitchFamily="34" charset="-122"/>
-                <a:cs typeface="Calibri" pitchFamily="34" charset="-120"/>
-              </a:rPr>
-              <a:t>+ alternativaEscolhida</a:t>
-            </a:r>
-            <a:endParaRPr lang="en-US" sz="1100" dirty="0"/>
-          </a:p>
-          <a:p>
-            <a:pPr algn="l" indent="0" marL="0">
-              <a:lnSpc>
-                <a:spcPts val="1872"/>
-              </a:lnSpc>
-              <a:buNone/>
-            </a:pPr>
-            <a:r>
-              <a:rPr lang="en-US" sz="1100" dirty="0">
-                <a:solidFill>
-                  <a:srgbClr val="5B6068"/>
-                </a:solidFill>
-                <a:latin typeface="Calibri" pitchFamily="34" charset="0"/>
-                <a:ea typeface="Calibri" pitchFamily="34" charset="-122"/>
-                <a:cs typeface="Calibri" pitchFamily="34" charset="-120"/>
-              </a:rPr>
-              <a:t>+ correta</a:t>
-            </a:r>
-            <a:endParaRPr lang="en-US" sz="1100" dirty="0"/>
-          </a:p>
-        </p:txBody>
-      </p:sp>
-      <p:sp>
-        <p:nvSpPr>
-          <p:cNvPr id="19" name="Shape 17"/>
-          <p:cNvSpPr/>
-          <p:nvPr/>
-        </p:nvSpPr>
-        <p:spPr>
-          <a:xfrm>
-            <a:off x="9372600" y="2103120"/>
-            <a:ext cx="2057400" cy="1005840"/>
-          </a:xfrm>
-          <a:prstGeom prst="rect">
-            <a:avLst/>
-          </a:prstGeom>
-          <a:solidFill>
-            <a:srgbClr val="FFFFFF"/>
-          </a:solidFill>
-          <a:ln w="12700">
-            <a:solidFill>
-              <a:srgbClr val="1B1E24"/>
-            </a:solidFill>
-            <a:prstDash val="solid"/>
-          </a:ln>
-        </p:spPr>
-      </p:sp>
-      <p:sp>
-        <p:nvSpPr>
-          <p:cNvPr id="20" name="Text 18"/>
-          <p:cNvSpPr/>
-          <p:nvPr/>
-        </p:nvSpPr>
-        <p:spPr>
-          <a:xfrm>
-            <a:off x="9372600" y="2103120"/>
-            <a:ext cx="2057400" cy="402336"/>
-          </a:xfrm>
-          <a:prstGeom prst="rect">
-            <a:avLst/>
-          </a:prstGeom>
-          <a:noFill/>
-          <a:ln/>
-        </p:spPr>
-        <p:txBody>
-          <a:bodyPr wrap="square" lIns="0" tIns="0" rIns="0" bIns="0" rtlCol="0" anchor="ctr"/>
-          <a:lstStyle/>
-          <a:p>
-            <a:pPr algn="ctr" indent="0" marL="0">
-              <a:lnSpc>
-                <a:spcPct val="100000"/>
-              </a:lnSpc>
-              <a:buNone/>
-            </a:pPr>
-            <a:r>
-              <a:rPr lang="en-US" sz="1250" b="1" dirty="0">
-                <a:solidFill>
-                  <a:srgbClr val="1B1E24"/>
-                </a:solidFill>
-                <a:latin typeface="Calibri" pitchFamily="34" charset="0"/>
-                <a:ea typeface="Calibri" pitchFamily="34" charset="-122"/>
-                <a:cs typeface="Calibri" pitchFamily="34" charset="-120"/>
-              </a:rPr>
-              <a:t>EdicaoEnem</a:t>
-            </a:r>
-            <a:endParaRPr lang="en-US" sz="1250" dirty="0"/>
-          </a:p>
-        </p:txBody>
-      </p:sp>
-      <p:sp>
-        <p:nvSpPr>
-          <p:cNvPr id="21" name="Shape 19"/>
-          <p:cNvSpPr/>
-          <p:nvPr/>
-        </p:nvSpPr>
-        <p:spPr>
-          <a:xfrm>
-            <a:off x="9372600" y="2505456"/>
-            <a:ext cx="2057400" cy="0"/>
-          </a:xfrm>
-          <a:prstGeom prst="line">
-            <a:avLst/>
-          </a:prstGeom>
-          <a:noFill/>
-          <a:ln w="9525">
-            <a:solidFill>
-              <a:srgbClr val="1B1E24"/>
-            </a:solidFill>
-            <a:prstDash val="solid"/>
-          </a:ln>
-        </p:spPr>
-      </p:sp>
-      <p:sp>
-        <p:nvSpPr>
-          <p:cNvPr id="22" name="Text 20"/>
-          <p:cNvSpPr/>
-          <p:nvPr/>
-        </p:nvSpPr>
-        <p:spPr>
-          <a:xfrm>
-            <a:off x="9500616" y="2532888"/>
-            <a:ext cx="1874520" cy="475488"/>
-          </a:xfrm>
-          <a:prstGeom prst="rect">
-            <a:avLst/>
-          </a:prstGeom>
-          <a:noFill/>
-          <a:ln/>
-        </p:spPr>
-        <p:txBody>
-          <a:bodyPr wrap="square" lIns="0" tIns="0" rIns="0" bIns="0" rtlCol="0" anchor="t"/>
-          <a:lstStyle/>
-          <a:p>
-            <a:pPr algn="l" indent="0" marL="0">
-              <a:lnSpc>
-                <a:spcPts val="1872"/>
-              </a:lnSpc>
-              <a:buNone/>
-            </a:pPr>
-            <a:r>
-              <a:rPr lang="en-US" sz="1100" dirty="0">
-                <a:solidFill>
-                  <a:srgbClr val="5B6068"/>
-                </a:solidFill>
-                <a:latin typeface="Calibri" pitchFamily="34" charset="0"/>
-                <a:ea typeface="Calibri" pitchFamily="34" charset="-122"/>
-                <a:cs typeface="Calibri" pitchFamily="34" charset="-120"/>
-              </a:rPr>
-              <a:t>+ ano</a:t>
-            </a:r>
-            <a:endParaRPr lang="en-US" sz="1100" dirty="0"/>
-          </a:p>
-          <a:p>
-            <a:pPr algn="l" indent="0" marL="0">
-              <a:lnSpc>
-                <a:spcPts val="1872"/>
-              </a:lnSpc>
-              <a:buNone/>
-            </a:pPr>
-            <a:r>
-              <a:rPr lang="en-US" sz="1100" dirty="0">
-                <a:solidFill>
-                  <a:srgbClr val="5B6068"/>
-                </a:solidFill>
-                <a:latin typeface="Calibri" pitchFamily="34" charset="0"/>
-                <a:ea typeface="Calibri" pitchFamily="34" charset="-122"/>
-                <a:cs typeface="Calibri" pitchFamily="34" charset="-120"/>
-              </a:rPr>
-              <a:t>+ descricao</a:t>
-            </a:r>
-            <a:endParaRPr lang="en-US" sz="1100" dirty="0"/>
-          </a:p>
-        </p:txBody>
-      </p:sp>
-      <p:sp>
-        <p:nvSpPr>
-          <p:cNvPr id="23" name="Shape 21"/>
-          <p:cNvSpPr/>
-          <p:nvPr/>
-        </p:nvSpPr>
-        <p:spPr>
-          <a:xfrm>
-            <a:off x="3611880" y="3840480"/>
-            <a:ext cx="2057400" cy="1481328"/>
-          </a:xfrm>
-          <a:prstGeom prst="rect">
-            <a:avLst/>
-          </a:prstGeom>
-          <a:solidFill>
-            <a:srgbClr val="FFFFFF"/>
-          </a:solidFill>
-          <a:ln w="12700">
-            <a:solidFill>
-              <a:srgbClr val="1B1E24"/>
-            </a:solidFill>
-            <a:prstDash val="solid"/>
-          </a:ln>
-        </p:spPr>
-      </p:sp>
-      <p:sp>
-        <p:nvSpPr>
-          <p:cNvPr id="24" name="Text 22"/>
-          <p:cNvSpPr/>
-          <p:nvPr/>
-        </p:nvSpPr>
-        <p:spPr>
-          <a:xfrm>
-            <a:off x="3611880" y="3840480"/>
-            <a:ext cx="2057400" cy="402336"/>
-          </a:xfrm>
-          <a:prstGeom prst="rect">
-            <a:avLst/>
-          </a:prstGeom>
-          <a:noFill/>
-          <a:ln/>
-        </p:spPr>
-        <p:txBody>
-          <a:bodyPr wrap="square" lIns="0" tIns="0" rIns="0" bIns="0" rtlCol="0" anchor="ctr"/>
-          <a:lstStyle/>
-          <a:p>
-            <a:pPr algn="ctr" indent="0" marL="0">
-              <a:lnSpc>
-                <a:spcPct val="100000"/>
-              </a:lnSpc>
-              <a:buNone/>
-            </a:pPr>
-            <a:r>
-              <a:rPr lang="en-US" sz="1250" b="1" dirty="0">
-                <a:solidFill>
-                  <a:srgbClr val="1B1E24"/>
-                </a:solidFill>
-                <a:latin typeface="Calibri" pitchFamily="34" charset="0"/>
-                <a:ea typeface="Calibri" pitchFamily="34" charset="-122"/>
-                <a:cs typeface="Calibri" pitchFamily="34" charset="-120"/>
-              </a:rPr>
-              <a:t>Resultado</a:t>
-            </a:r>
-            <a:endParaRPr lang="en-US" sz="1250" dirty="0"/>
-          </a:p>
-        </p:txBody>
-      </p:sp>
-      <p:sp>
-        <p:nvSpPr>
-          <p:cNvPr id="25" name="Shape 23"/>
-          <p:cNvSpPr/>
-          <p:nvPr/>
-        </p:nvSpPr>
-        <p:spPr>
-          <a:xfrm>
-            <a:off x="3611880" y="4242816"/>
-            <a:ext cx="2057400" cy="0"/>
-          </a:xfrm>
-          <a:prstGeom prst="line">
-            <a:avLst/>
-          </a:prstGeom>
-          <a:noFill/>
-          <a:ln w="9525">
-            <a:solidFill>
-              <a:srgbClr val="1B1E24"/>
-            </a:solidFill>
-            <a:prstDash val="solid"/>
-          </a:ln>
-        </p:spPr>
-      </p:sp>
-      <p:sp>
-        <p:nvSpPr>
-          <p:cNvPr id="26" name="Text 24"/>
-          <p:cNvSpPr/>
-          <p:nvPr/>
-        </p:nvSpPr>
-        <p:spPr>
-          <a:xfrm>
-            <a:off x="3739896" y="4270248"/>
-            <a:ext cx="1874520" cy="950976"/>
-          </a:xfrm>
-          <a:prstGeom prst="rect">
-            <a:avLst/>
-          </a:prstGeom>
-          <a:noFill/>
-          <a:ln/>
-        </p:spPr>
-        <p:txBody>
-          <a:bodyPr wrap="square" lIns="0" tIns="0" rIns="0" bIns="0" rtlCol="0" anchor="t"/>
-          <a:lstStyle/>
-          <a:p>
-            <a:pPr algn="l" indent="0" marL="0">
-              <a:lnSpc>
-                <a:spcPts val="1872"/>
-              </a:lnSpc>
-              <a:buNone/>
-            </a:pPr>
-            <a:r>
-              <a:rPr lang="en-US" sz="1100" dirty="0">
-                <a:solidFill>
-                  <a:srgbClr val="5B6068"/>
-                </a:solidFill>
-                <a:latin typeface="Calibri" pitchFamily="34" charset="0"/>
-                <a:ea typeface="Calibri" pitchFamily="34" charset="-122"/>
-                <a:cs typeface="Calibri" pitchFamily="34" charset="-120"/>
-              </a:rPr>
-              <a:t>+ notaTri</a:t>
-            </a:r>
-            <a:endParaRPr lang="en-US" sz="1100" dirty="0"/>
-          </a:p>
-          <a:p>
-            <a:pPr algn="l" indent="0" marL="0">
-              <a:lnSpc>
-                <a:spcPts val="1872"/>
-              </a:lnSpc>
-              <a:buNone/>
-            </a:pPr>
-            <a:r>
-              <a:rPr lang="en-US" sz="1100" dirty="0">
-                <a:solidFill>
-                  <a:srgbClr val="5B6068"/>
-                </a:solidFill>
-                <a:latin typeface="Calibri" pitchFamily="34" charset="0"/>
-                <a:ea typeface="Calibri" pitchFamily="34" charset="-122"/>
-                <a:cs typeface="Calibri" pitchFamily="34" charset="-120"/>
-              </a:rPr>
-              <a:t>+ acertos</a:t>
-            </a:r>
-            <a:endParaRPr lang="en-US" sz="1100" dirty="0"/>
-          </a:p>
-          <a:p>
-            <a:pPr algn="l" indent="0" marL="0">
-              <a:lnSpc>
-                <a:spcPts val="1872"/>
-              </a:lnSpc>
-              <a:buNone/>
-            </a:pPr>
-            <a:r>
-              <a:rPr lang="en-US" sz="1100" dirty="0">
-                <a:solidFill>
-                  <a:srgbClr val="5B6068"/>
-                </a:solidFill>
-                <a:latin typeface="Calibri" pitchFamily="34" charset="0"/>
-                <a:ea typeface="Calibri" pitchFamily="34" charset="-122"/>
-                <a:cs typeface="Calibri" pitchFamily="34" charset="-120"/>
-              </a:rPr>
-              <a:t>+ erros</a:t>
-            </a:r>
-            <a:endParaRPr lang="en-US" sz="1100" dirty="0"/>
-          </a:p>
-          <a:p>
-            <a:pPr algn="l" indent="0" marL="0">
-              <a:lnSpc>
-                <a:spcPts val="1872"/>
-              </a:lnSpc>
-              <a:buNone/>
-            </a:pPr>
-            <a:r>
-              <a:rPr lang="en-US" sz="1100" dirty="0">
-                <a:solidFill>
-                  <a:srgbClr val="5B6068"/>
-                </a:solidFill>
-                <a:latin typeface="Calibri" pitchFamily="34" charset="0"/>
-                <a:ea typeface="Calibri" pitchFamily="34" charset="-122"/>
-                <a:cs typeface="Calibri" pitchFamily="34" charset="-120"/>
-              </a:rPr>
-              <a:t>+ dataCalculo</a:t>
-            </a:r>
-            <a:endParaRPr lang="en-US" sz="1100" dirty="0"/>
-          </a:p>
-        </p:txBody>
-      </p:sp>
-      <p:sp>
-        <p:nvSpPr>
-          <p:cNvPr id="27" name="Shape 25"/>
-          <p:cNvSpPr/>
-          <p:nvPr/>
-        </p:nvSpPr>
-        <p:spPr>
-          <a:xfrm>
-            <a:off x="6492240" y="3840480"/>
-            <a:ext cx="2057400" cy="1243584"/>
-          </a:xfrm>
-          <a:prstGeom prst="rect">
-            <a:avLst/>
-          </a:prstGeom>
-          <a:solidFill>
-            <a:srgbClr val="FFFFFF"/>
-          </a:solidFill>
-          <a:ln w="12700">
-            <a:solidFill>
-              <a:srgbClr val="1B1E24"/>
-            </a:solidFill>
-            <a:prstDash val="solid"/>
-          </a:ln>
-        </p:spPr>
-      </p:sp>
-      <p:sp>
-        <p:nvSpPr>
-          <p:cNvPr id="28" name="Text 26"/>
-          <p:cNvSpPr/>
-          <p:nvPr/>
-        </p:nvSpPr>
-        <p:spPr>
-          <a:xfrm>
-            <a:off x="6492240" y="3840480"/>
-            <a:ext cx="2057400" cy="402336"/>
-          </a:xfrm>
-          <a:prstGeom prst="rect">
-            <a:avLst/>
-          </a:prstGeom>
-          <a:noFill/>
-          <a:ln/>
-        </p:spPr>
-        <p:txBody>
-          <a:bodyPr wrap="square" lIns="0" tIns="0" rIns="0" bIns="0" rtlCol="0" anchor="ctr"/>
-          <a:lstStyle/>
-          <a:p>
-            <a:pPr algn="ctr" indent="0" marL="0">
-              <a:lnSpc>
-                <a:spcPct val="100000"/>
-              </a:lnSpc>
-              <a:buNone/>
-            </a:pPr>
-            <a:r>
-              <a:rPr lang="en-US" sz="1250" b="1" dirty="0">
-                <a:solidFill>
-                  <a:srgbClr val="1B1E24"/>
-                </a:solidFill>
-                <a:latin typeface="Calibri" pitchFamily="34" charset="0"/>
-                <a:ea typeface="Calibri" pitchFamily="34" charset="-122"/>
-                <a:cs typeface="Calibri" pitchFamily="34" charset="-120"/>
-              </a:rPr>
-              <a:t>Questao</a:t>
-            </a:r>
-            <a:endParaRPr lang="en-US" sz="1250" dirty="0"/>
-          </a:p>
-        </p:txBody>
-      </p:sp>
-      <p:sp>
-        <p:nvSpPr>
-          <p:cNvPr id="29" name="Shape 27"/>
-          <p:cNvSpPr/>
-          <p:nvPr/>
-        </p:nvSpPr>
-        <p:spPr>
-          <a:xfrm>
-            <a:off x="6492240" y="4242816"/>
-            <a:ext cx="2057400" cy="0"/>
-          </a:xfrm>
-          <a:prstGeom prst="line">
-            <a:avLst/>
-          </a:prstGeom>
-          <a:noFill/>
-          <a:ln w="9525">
-            <a:solidFill>
-              <a:srgbClr val="1B1E24"/>
-            </a:solidFill>
-            <a:prstDash val="solid"/>
-          </a:ln>
-        </p:spPr>
-      </p:sp>
-      <p:sp>
-        <p:nvSpPr>
-          <p:cNvPr id="30" name="Text 28"/>
-          <p:cNvSpPr/>
-          <p:nvPr/>
-        </p:nvSpPr>
-        <p:spPr>
-          <a:xfrm>
-            <a:off x="6620256" y="4270248"/>
-            <a:ext cx="1874520" cy="713232"/>
-          </a:xfrm>
-          <a:prstGeom prst="rect">
-            <a:avLst/>
-          </a:prstGeom>
-          <a:noFill/>
-          <a:ln/>
-        </p:spPr>
-        <p:txBody>
-          <a:bodyPr wrap="square" lIns="0" tIns="0" rIns="0" bIns="0" rtlCol="0" anchor="t"/>
-          <a:lstStyle/>
-          <a:p>
-            <a:pPr algn="l" indent="0" marL="0">
-              <a:lnSpc>
-                <a:spcPts val="1872"/>
-              </a:lnSpc>
-              <a:buNone/>
-            </a:pPr>
-            <a:r>
-              <a:rPr lang="en-US" sz="1100" dirty="0">
-                <a:solidFill>
-                  <a:srgbClr val="5B6068"/>
-                </a:solidFill>
-                <a:latin typeface="Calibri" pitchFamily="34" charset="0"/>
-                <a:ea typeface="Calibri" pitchFamily="34" charset="-122"/>
-                <a:cs typeface="Calibri" pitchFamily="34" charset="-120"/>
-              </a:rPr>
-              <a:t>+ numero</a:t>
-            </a:r>
-            <a:endParaRPr lang="en-US" sz="1100" dirty="0"/>
-          </a:p>
-          <a:p>
-            <a:pPr algn="l" indent="0" marL="0">
-              <a:lnSpc>
-                <a:spcPts val="1872"/>
-              </a:lnSpc>
-              <a:buNone/>
-            </a:pPr>
-            <a:r>
-              <a:rPr lang="en-US" sz="1100" dirty="0">
-                <a:solidFill>
-                  <a:srgbClr val="5B6068"/>
-                </a:solidFill>
-                <a:latin typeface="Calibri" pitchFamily="34" charset="0"/>
-                <a:ea typeface="Calibri" pitchFamily="34" charset="-122"/>
-                <a:cs typeface="Calibri" pitchFamily="34" charset="-120"/>
-              </a:rPr>
-              <a:t>+ enunciadoRef</a:t>
-            </a:r>
-            <a:endParaRPr lang="en-US" sz="1100" dirty="0"/>
-          </a:p>
-          <a:p>
-            <a:pPr algn="l" indent="0" marL="0">
-              <a:lnSpc>
-                <a:spcPts val="1872"/>
-              </a:lnSpc>
-              <a:buNone/>
-            </a:pPr>
-            <a:r>
-              <a:rPr lang="en-US" sz="1100" dirty="0">
-                <a:solidFill>
-                  <a:srgbClr val="5B6068"/>
-                </a:solidFill>
-                <a:latin typeface="Calibri" pitchFamily="34" charset="0"/>
-                <a:ea typeface="Calibri" pitchFamily="34" charset="-122"/>
-                <a:cs typeface="Calibri" pitchFamily="34" charset="-120"/>
-              </a:rPr>
-              <a:t>+ gabarito</a:t>
-            </a:r>
-            <a:endParaRPr lang="en-US" sz="1100" dirty="0"/>
-          </a:p>
-        </p:txBody>
-      </p:sp>
-      <p:sp>
-        <p:nvSpPr>
-          <p:cNvPr id="31" name="Shape 29"/>
-          <p:cNvSpPr/>
-          <p:nvPr/>
-        </p:nvSpPr>
-        <p:spPr>
-          <a:xfrm>
-            <a:off x="9372600" y="3840480"/>
-            <a:ext cx="2057400" cy="1243584"/>
-          </a:xfrm>
-          <a:prstGeom prst="rect">
-            <a:avLst/>
-          </a:prstGeom>
-          <a:solidFill>
-            <a:srgbClr val="FFFFFF"/>
-          </a:solidFill>
-          <a:ln w="12700">
-            <a:solidFill>
-              <a:srgbClr val="1B1E24"/>
-            </a:solidFill>
-            <a:prstDash val="solid"/>
-          </a:ln>
-        </p:spPr>
-      </p:sp>
-      <p:sp>
-        <p:nvSpPr>
-          <p:cNvPr id="32" name="Text 30"/>
-          <p:cNvSpPr/>
-          <p:nvPr/>
-        </p:nvSpPr>
-        <p:spPr>
-          <a:xfrm>
-            <a:off x="9372600" y="3840480"/>
-            <a:ext cx="2057400" cy="402336"/>
-          </a:xfrm>
-          <a:prstGeom prst="rect">
-            <a:avLst/>
-          </a:prstGeom>
-          <a:noFill/>
-          <a:ln/>
-        </p:spPr>
-        <p:txBody>
-          <a:bodyPr wrap="square" lIns="0" tIns="0" rIns="0" bIns="0" rtlCol="0" anchor="ctr"/>
-          <a:lstStyle/>
-          <a:p>
-            <a:pPr algn="ctr" indent="0" marL="0">
-              <a:lnSpc>
-                <a:spcPct val="100000"/>
-              </a:lnSpc>
-              <a:buNone/>
-            </a:pPr>
-            <a:r>
-              <a:rPr lang="en-US" sz="1250" b="1" dirty="0">
-                <a:solidFill>
-                  <a:srgbClr val="1B1E24"/>
-                </a:solidFill>
-                <a:latin typeface="Calibri" pitchFamily="34" charset="0"/>
-                <a:ea typeface="Calibri" pitchFamily="34" charset="-122"/>
-                <a:cs typeface="Calibri" pitchFamily="34" charset="-120"/>
-              </a:rPr>
-              <a:t>ParametroItem</a:t>
-            </a:r>
-            <a:endParaRPr lang="en-US" sz="1250" dirty="0"/>
-          </a:p>
-        </p:txBody>
-      </p:sp>
-      <p:sp>
-        <p:nvSpPr>
-          <p:cNvPr id="33" name="Shape 31"/>
-          <p:cNvSpPr/>
-          <p:nvPr/>
-        </p:nvSpPr>
-        <p:spPr>
-          <a:xfrm>
-            <a:off x="9372600" y="4242816"/>
-            <a:ext cx="2057400" cy="0"/>
-          </a:xfrm>
-          <a:prstGeom prst="line">
-            <a:avLst/>
-          </a:prstGeom>
-          <a:noFill/>
-          <a:ln w="9525">
-            <a:solidFill>
-              <a:srgbClr val="1B1E24"/>
-            </a:solidFill>
-            <a:prstDash val="solid"/>
-          </a:ln>
-        </p:spPr>
-      </p:sp>
-      <p:sp>
-        <p:nvSpPr>
-          <p:cNvPr id="34" name="Text 32"/>
-          <p:cNvSpPr/>
-          <p:nvPr/>
-        </p:nvSpPr>
-        <p:spPr>
-          <a:xfrm>
-            <a:off x="9500616" y="4270248"/>
-            <a:ext cx="1874520" cy="713232"/>
-          </a:xfrm>
-          <a:prstGeom prst="rect">
-            <a:avLst/>
-          </a:prstGeom>
-          <a:noFill/>
-          <a:ln/>
-        </p:spPr>
-        <p:txBody>
-          <a:bodyPr wrap="square" lIns="0" tIns="0" rIns="0" bIns="0" rtlCol="0" anchor="t"/>
-          <a:lstStyle/>
-          <a:p>
-            <a:pPr algn="l" indent="0" marL="0">
-              <a:lnSpc>
-                <a:spcPts val="1872"/>
-              </a:lnSpc>
-              <a:buNone/>
-            </a:pPr>
-            <a:r>
-              <a:rPr lang="en-US" sz="1100" dirty="0">
-                <a:solidFill>
-                  <a:srgbClr val="5B6068"/>
-                </a:solidFill>
-                <a:latin typeface="Calibri" pitchFamily="34" charset="0"/>
-                <a:ea typeface="Calibri" pitchFamily="34" charset="-122"/>
-                <a:cs typeface="Calibri" pitchFamily="34" charset="-120"/>
-              </a:rPr>
-              <a:t>+ discriminacao</a:t>
-            </a:r>
-            <a:endParaRPr lang="en-US" sz="1100" dirty="0"/>
-          </a:p>
-          <a:p>
-            <a:pPr algn="l" indent="0" marL="0">
-              <a:lnSpc>
-                <a:spcPts val="1872"/>
-              </a:lnSpc>
-              <a:buNone/>
-            </a:pPr>
-            <a:r>
-              <a:rPr lang="en-US" sz="1100" dirty="0">
-                <a:solidFill>
-                  <a:srgbClr val="5B6068"/>
-                </a:solidFill>
-                <a:latin typeface="Calibri" pitchFamily="34" charset="0"/>
-                <a:ea typeface="Calibri" pitchFamily="34" charset="-122"/>
-                <a:cs typeface="Calibri" pitchFamily="34" charset="-120"/>
-              </a:rPr>
-              <a:t>+ dificuldade</a:t>
-            </a:r>
-            <a:endParaRPr lang="en-US" sz="1100" dirty="0"/>
-          </a:p>
-          <a:p>
-            <a:pPr algn="l" indent="0" marL="0">
-              <a:lnSpc>
-                <a:spcPts val="1872"/>
-              </a:lnSpc>
-              <a:buNone/>
-            </a:pPr>
-            <a:r>
-              <a:rPr lang="en-US" sz="1100" dirty="0">
-                <a:solidFill>
-                  <a:srgbClr val="5B6068"/>
-                </a:solidFill>
-                <a:latin typeface="Calibri" pitchFamily="34" charset="0"/>
-                <a:ea typeface="Calibri" pitchFamily="34" charset="-122"/>
-                <a:cs typeface="Calibri" pitchFamily="34" charset="-120"/>
-              </a:rPr>
-              <a:t>+ acaso</a:t>
-            </a:r>
-            <a:endParaRPr lang="en-US" sz="1100" dirty="0"/>
-          </a:p>
-        </p:txBody>
-      </p:sp>
-      <p:sp>
-        <p:nvSpPr>
-          <p:cNvPr id="35" name="Shape 33"/>
-          <p:cNvSpPr/>
-          <p:nvPr/>
-        </p:nvSpPr>
-        <p:spPr>
-          <a:xfrm>
-            <a:off x="5052060" y="5532120"/>
-            <a:ext cx="2057400" cy="1005840"/>
-          </a:xfrm>
-          <a:prstGeom prst="rect">
-            <a:avLst/>
-          </a:prstGeom>
-          <a:solidFill>
-            <a:srgbClr val="FFFFFF"/>
-          </a:solidFill>
-          <a:ln w="12700">
-            <a:solidFill>
-              <a:srgbClr val="1B1E24"/>
-            </a:solidFill>
-            <a:prstDash val="solid"/>
-          </a:ln>
-        </p:spPr>
-      </p:sp>
-      <p:sp>
-        <p:nvSpPr>
-          <p:cNvPr id="36" name="Text 34"/>
-          <p:cNvSpPr/>
-          <p:nvPr/>
-        </p:nvSpPr>
-        <p:spPr>
-          <a:xfrm>
-            <a:off x="5052060" y="5532120"/>
-            <a:ext cx="2057400" cy="402336"/>
-          </a:xfrm>
-          <a:prstGeom prst="rect">
-            <a:avLst/>
-          </a:prstGeom>
-          <a:noFill/>
-          <a:ln/>
-        </p:spPr>
-        <p:txBody>
-          <a:bodyPr wrap="square" lIns="0" tIns="0" rIns="0" bIns="0" rtlCol="0" anchor="ctr"/>
-          <a:lstStyle/>
-          <a:p>
-            <a:pPr algn="ctr" indent="0" marL="0">
-              <a:lnSpc>
-                <a:spcPct val="100000"/>
-              </a:lnSpc>
-              <a:buNone/>
-            </a:pPr>
-            <a:r>
-              <a:rPr lang="en-US" sz="1250" b="1" dirty="0">
-                <a:solidFill>
-                  <a:srgbClr val="1B1E24"/>
-                </a:solidFill>
-                <a:latin typeface="Calibri" pitchFamily="34" charset="0"/>
-                <a:ea typeface="Calibri" pitchFamily="34" charset="-122"/>
-                <a:cs typeface="Calibri" pitchFamily="34" charset="-120"/>
-              </a:rPr>
-              <a:t>AreaConhecimento</a:t>
-            </a:r>
-            <a:endParaRPr lang="en-US" sz="1250" dirty="0"/>
-          </a:p>
-        </p:txBody>
-      </p:sp>
-      <p:sp>
-        <p:nvSpPr>
-          <p:cNvPr id="37" name="Shape 35"/>
-          <p:cNvSpPr/>
-          <p:nvPr/>
-        </p:nvSpPr>
-        <p:spPr>
-          <a:xfrm>
-            <a:off x="5052060" y="5934456"/>
-            <a:ext cx="2057400" cy="0"/>
-          </a:xfrm>
-          <a:prstGeom prst="line">
-            <a:avLst/>
-          </a:prstGeom>
-          <a:noFill/>
-          <a:ln w="9525">
-            <a:solidFill>
-              <a:srgbClr val="1B1E24"/>
-            </a:solidFill>
-            <a:prstDash val="solid"/>
-          </a:ln>
-        </p:spPr>
-      </p:sp>
-      <p:sp>
-        <p:nvSpPr>
-          <p:cNvPr id="38" name="Text 36"/>
-          <p:cNvSpPr/>
-          <p:nvPr/>
-        </p:nvSpPr>
-        <p:spPr>
-          <a:xfrm>
-            <a:off x="5180076" y="5961888"/>
-            <a:ext cx="1874520" cy="475488"/>
-          </a:xfrm>
-          <a:prstGeom prst="rect">
-            <a:avLst/>
-          </a:prstGeom>
-          <a:noFill/>
-          <a:ln/>
-        </p:spPr>
-        <p:txBody>
-          <a:bodyPr wrap="square" lIns="0" tIns="0" rIns="0" bIns="0" rtlCol="0" anchor="t"/>
-          <a:lstStyle/>
-          <a:p>
-            <a:pPr algn="l" indent="0" marL="0">
-              <a:lnSpc>
-                <a:spcPts val="1872"/>
-              </a:lnSpc>
-              <a:buNone/>
-            </a:pPr>
-            <a:r>
-              <a:rPr lang="en-US" sz="1100" dirty="0">
-                <a:solidFill>
-                  <a:srgbClr val="5B6068"/>
-                </a:solidFill>
-                <a:latin typeface="Calibri" pitchFamily="34" charset="0"/>
-                <a:ea typeface="Calibri" pitchFamily="34" charset="-122"/>
-                <a:cs typeface="Calibri" pitchFamily="34" charset="-120"/>
-              </a:rPr>
-              <a:t>+ sigla</a:t>
-            </a:r>
-            <a:endParaRPr lang="en-US" sz="1100" dirty="0"/>
-          </a:p>
-          <a:p>
-            <a:pPr algn="l" indent="0" marL="0">
-              <a:lnSpc>
-                <a:spcPts val="1872"/>
-              </a:lnSpc>
-              <a:buNone/>
-            </a:pPr>
-            <a:r>
-              <a:rPr lang="en-US" sz="1100" dirty="0">
-                <a:solidFill>
-                  <a:srgbClr val="5B6068"/>
-                </a:solidFill>
-                <a:latin typeface="Calibri" pitchFamily="34" charset="0"/>
-                <a:ea typeface="Calibri" pitchFamily="34" charset="-122"/>
-                <a:cs typeface="Calibri" pitchFamily="34" charset="-120"/>
-              </a:rPr>
-              <a:t>+ nome</a:t>
-            </a:r>
-            <a:endParaRPr lang="en-US" sz="1100" dirty="0"/>
-          </a:p>
-        </p:txBody>
-      </p:sp>
-      <p:sp>
-        <p:nvSpPr>
-          <p:cNvPr id="39" name="Shape 37"/>
-          <p:cNvSpPr/>
-          <p:nvPr/>
-        </p:nvSpPr>
-        <p:spPr>
-          <a:xfrm>
-            <a:off x="2788920" y="2651760"/>
-            <a:ext cx="822960" cy="0"/>
-          </a:xfrm>
-          <a:prstGeom prst="line">
-            <a:avLst/>
-          </a:prstGeom>
-          <a:noFill/>
-          <a:ln w="12700">
-            <a:solidFill>
-              <a:srgbClr val="5B6068"/>
-            </a:solidFill>
-            <a:prstDash val="solid"/>
-            <a:tailEnd type="arrow"/>
-          </a:ln>
-        </p:spPr>
-      </p:sp>
-      <p:sp>
-        <p:nvSpPr>
-          <p:cNvPr id="40" name="Text 38"/>
-          <p:cNvSpPr/>
-          <p:nvPr/>
-        </p:nvSpPr>
-        <p:spPr>
-          <a:xfrm>
-            <a:off x="2807208" y="2377440"/>
-            <a:ext cx="786384" cy="182880"/>
-          </a:xfrm>
-          <a:prstGeom prst="rect">
-            <a:avLst/>
-          </a:prstGeom>
-          <a:solidFill>
-            <a:srgbClr val="F7F6F3"/>
-          </a:solidFill>
-          <a:ln/>
-        </p:spPr>
-        <p:txBody>
-          <a:bodyPr wrap="square" lIns="0" tIns="0" rIns="0" bIns="0" rtlCol="0" anchor="ctr"/>
-          <a:lstStyle/>
-          <a:p>
-            <a:pPr algn="ctr" indent="0" marL="0">
-              <a:lnSpc>
-                <a:spcPct val="100000"/>
-              </a:lnSpc>
-              <a:buNone/>
-            </a:pPr>
-            <a:r>
-              <a:rPr lang="en-US" sz="900" dirty="0">
-                <a:solidFill>
-                  <a:srgbClr val="5B6068"/>
-                </a:solidFill>
-                <a:latin typeface="Calibri" pitchFamily="34" charset="0"/>
-                <a:ea typeface="Calibri" pitchFamily="34" charset="-122"/>
-                <a:cs typeface="Calibri" pitchFamily="34" charset="-120"/>
-              </a:rPr>
-              <a:t>realiza  1..*</a:t>
-            </a:r>
-            <a:endParaRPr lang="en-US" sz="900" dirty="0"/>
-          </a:p>
-        </p:txBody>
-      </p:sp>
-      <p:sp>
-        <p:nvSpPr>
-          <p:cNvPr id="41" name="Shape 39"/>
-          <p:cNvSpPr/>
-          <p:nvPr/>
-        </p:nvSpPr>
-        <p:spPr>
-          <a:xfrm>
-            <a:off x="5669280" y="2651760"/>
-            <a:ext cx="822960" cy="0"/>
-          </a:xfrm>
-          <a:prstGeom prst="line">
-            <a:avLst/>
-          </a:prstGeom>
-          <a:noFill/>
-          <a:ln w="12700">
-            <a:solidFill>
-              <a:srgbClr val="5B6068"/>
-            </a:solidFill>
-            <a:prstDash val="solid"/>
-            <a:tailEnd type="arrow"/>
-          </a:ln>
-        </p:spPr>
-      </p:sp>
-      <p:sp>
-        <p:nvSpPr>
-          <p:cNvPr id="42" name="Text 40"/>
-          <p:cNvSpPr/>
-          <p:nvPr/>
-        </p:nvSpPr>
-        <p:spPr>
-          <a:xfrm>
-            <a:off x="5687568" y="2377440"/>
-            <a:ext cx="786384" cy="182880"/>
-          </a:xfrm>
-          <a:prstGeom prst="rect">
-            <a:avLst/>
-          </a:prstGeom>
-          <a:solidFill>
-            <a:srgbClr val="F7F6F3"/>
-          </a:solidFill>
-          <a:ln/>
-        </p:spPr>
-        <p:txBody>
-          <a:bodyPr wrap="square" lIns="0" tIns="0" rIns="0" bIns="0" rtlCol="0" anchor="ctr"/>
-          <a:lstStyle/>
-          <a:p>
-            <a:pPr algn="ctr" indent="0" marL="0">
-              <a:lnSpc>
-                <a:spcPct val="100000"/>
-              </a:lnSpc>
-              <a:buNone/>
-            </a:pPr>
-            <a:r>
-              <a:rPr lang="en-US" sz="900" dirty="0">
-                <a:solidFill>
-                  <a:srgbClr val="5B6068"/>
-                </a:solidFill>
-                <a:latin typeface="Calibri" pitchFamily="34" charset="0"/>
-                <a:ea typeface="Calibri" pitchFamily="34" charset="-122"/>
-                <a:cs typeface="Calibri" pitchFamily="34" charset="-120"/>
-              </a:rPr>
-              <a:t>contém  1..*</a:t>
-            </a:r>
-            <a:endParaRPr lang="en-US" sz="900" dirty="0"/>
-          </a:p>
-        </p:txBody>
-      </p:sp>
-      <p:sp>
-        <p:nvSpPr>
-          <p:cNvPr id="43" name="Shape 41"/>
-          <p:cNvSpPr/>
-          <p:nvPr/>
-        </p:nvSpPr>
-        <p:spPr>
-          <a:xfrm flipV="1">
-            <a:off x="4640580" y="1847088"/>
-            <a:ext cx="0" cy="256032"/>
-          </a:xfrm>
-          <a:prstGeom prst="line">
-            <a:avLst/>
-          </a:prstGeom>
-          <a:noFill/>
-          <a:ln w="12700">
-            <a:solidFill>
-              <a:srgbClr val="5B6068"/>
-            </a:solidFill>
-            <a:prstDash val="solid"/>
-          </a:ln>
-        </p:spPr>
-      </p:sp>
-      <p:sp>
-        <p:nvSpPr>
-          <p:cNvPr id="44" name="Shape 42"/>
-          <p:cNvSpPr/>
-          <p:nvPr/>
-        </p:nvSpPr>
-        <p:spPr>
-          <a:xfrm>
-            <a:off x="4640580" y="1847088"/>
-            <a:ext cx="5760720" cy="0"/>
-          </a:xfrm>
-          <a:prstGeom prst="line">
-            <a:avLst/>
-          </a:prstGeom>
-          <a:noFill/>
-          <a:ln w="12700">
-            <a:solidFill>
-              <a:srgbClr val="5B6068"/>
-            </a:solidFill>
-            <a:prstDash val="solid"/>
-          </a:ln>
-        </p:spPr>
-      </p:sp>
-      <p:sp>
-        <p:nvSpPr>
-          <p:cNvPr id="45" name="Shape 43"/>
-          <p:cNvSpPr/>
-          <p:nvPr/>
-        </p:nvSpPr>
-        <p:spPr>
-          <a:xfrm>
-            <a:off x="10401300" y="1847088"/>
-            <a:ext cx="0" cy="256032"/>
-          </a:xfrm>
-          <a:prstGeom prst="line">
-            <a:avLst/>
-          </a:prstGeom>
-          <a:noFill/>
-          <a:ln w="12700">
-            <a:solidFill>
-              <a:srgbClr val="5B6068"/>
-            </a:solidFill>
-            <a:prstDash val="solid"/>
-            <a:tailEnd type="arrow"/>
-          </a:ln>
-        </p:spPr>
-      </p:sp>
-      <p:sp>
-        <p:nvSpPr>
-          <p:cNvPr id="46" name="Text 44"/>
-          <p:cNvSpPr/>
-          <p:nvPr/>
-        </p:nvSpPr>
-        <p:spPr>
-          <a:xfrm>
-            <a:off x="6972300" y="1755648"/>
-            <a:ext cx="1097280" cy="182880"/>
-          </a:xfrm>
-          <a:prstGeom prst="rect">
-            <a:avLst/>
-          </a:prstGeom>
-          <a:solidFill>
-            <a:srgbClr val="F7F6F3"/>
-          </a:solidFill>
-          <a:ln/>
-        </p:spPr>
-        <p:txBody>
-          <a:bodyPr wrap="square" lIns="0" tIns="0" rIns="0" bIns="0" rtlCol="0" anchor="ctr"/>
-          <a:lstStyle/>
-          <a:p>
-            <a:pPr algn="ctr" indent="0" marL="0">
-              <a:lnSpc>
-                <a:spcPct val="100000"/>
-              </a:lnSpc>
-              <a:buNone/>
-            </a:pPr>
-            <a:r>
-              <a:rPr lang="en-US" sz="900" dirty="0">
-                <a:solidFill>
-                  <a:srgbClr val="5B6068"/>
-                </a:solidFill>
-                <a:latin typeface="Calibri" pitchFamily="34" charset="0"/>
-                <a:ea typeface="Calibri" pitchFamily="34" charset="-122"/>
-                <a:cs typeface="Calibri" pitchFamily="34" charset="-120"/>
-              </a:rPr>
-              <a:t>refere-se a  1</a:t>
-            </a:r>
-            <a:endParaRPr lang="en-US" sz="900" dirty="0"/>
-          </a:p>
-        </p:txBody>
-      </p:sp>
-      <p:sp>
-        <p:nvSpPr>
-          <p:cNvPr id="47" name="Shape 45"/>
-          <p:cNvSpPr/>
-          <p:nvPr/>
-        </p:nvSpPr>
-        <p:spPr>
-          <a:xfrm>
-            <a:off x="4640580" y="3108960"/>
-            <a:ext cx="0" cy="731520"/>
-          </a:xfrm>
-          <a:prstGeom prst="line">
-            <a:avLst/>
-          </a:prstGeom>
-          <a:noFill/>
-          <a:ln w="12700">
-            <a:solidFill>
-              <a:srgbClr val="5B6068"/>
-            </a:solidFill>
-            <a:prstDash val="solid"/>
-            <a:tailEnd type="arrow"/>
-          </a:ln>
-        </p:spPr>
-      </p:sp>
-      <p:sp>
-        <p:nvSpPr>
-          <p:cNvPr id="48" name="Text 46"/>
-          <p:cNvSpPr/>
-          <p:nvPr/>
-        </p:nvSpPr>
-        <p:spPr>
-          <a:xfrm>
-            <a:off x="4695444" y="3383280"/>
-            <a:ext cx="731520" cy="182880"/>
-          </a:xfrm>
-          <a:prstGeom prst="rect">
-            <a:avLst/>
-          </a:prstGeom>
-          <a:solidFill>
-            <a:srgbClr val="F7F6F3"/>
-          </a:solidFill>
-          <a:ln/>
-        </p:spPr>
-        <p:txBody>
-          <a:bodyPr wrap="square" lIns="0" tIns="0" rIns="0" bIns="0" rtlCol="0" anchor="ctr"/>
-          <a:lstStyle/>
-          <a:p>
-            <a:pPr algn="l" indent="0" marL="0">
-              <a:lnSpc>
-                <a:spcPct val="100000"/>
-              </a:lnSpc>
-              <a:buNone/>
-            </a:pPr>
-            <a:r>
-              <a:rPr lang="en-US" sz="900" dirty="0">
-                <a:solidFill>
-                  <a:srgbClr val="5B6068"/>
-                </a:solidFill>
-                <a:latin typeface="Calibri" pitchFamily="34" charset="0"/>
-                <a:ea typeface="Calibri" pitchFamily="34" charset="-122"/>
-                <a:cs typeface="Calibri" pitchFamily="34" charset="-120"/>
-              </a:rPr>
-              <a:t>gera  1..*</a:t>
-            </a:r>
-            <a:endParaRPr lang="en-US" sz="900" dirty="0"/>
-          </a:p>
-        </p:txBody>
-      </p:sp>
-      <p:sp>
-        <p:nvSpPr>
-          <p:cNvPr id="49" name="Shape 47"/>
-          <p:cNvSpPr/>
-          <p:nvPr/>
-        </p:nvSpPr>
-        <p:spPr>
-          <a:xfrm>
-            <a:off x="7520940" y="3108960"/>
-            <a:ext cx="0" cy="731520"/>
-          </a:xfrm>
-          <a:prstGeom prst="line">
-            <a:avLst/>
-          </a:prstGeom>
-          <a:noFill/>
-          <a:ln w="12700">
-            <a:solidFill>
-              <a:srgbClr val="5B6068"/>
-            </a:solidFill>
-            <a:prstDash val="solid"/>
-            <a:tailEnd type="arrow"/>
-          </a:ln>
-        </p:spPr>
-      </p:sp>
-      <p:sp>
-        <p:nvSpPr>
-          <p:cNvPr id="50" name="Text 48"/>
-          <p:cNvSpPr/>
-          <p:nvPr/>
-        </p:nvSpPr>
-        <p:spPr>
-          <a:xfrm>
-            <a:off x="7575804" y="3383280"/>
-            <a:ext cx="822960" cy="182880"/>
-          </a:xfrm>
-          <a:prstGeom prst="rect">
-            <a:avLst/>
-          </a:prstGeom>
-          <a:solidFill>
-            <a:srgbClr val="F7F6F3"/>
-          </a:solidFill>
-          <a:ln/>
-        </p:spPr>
-        <p:txBody>
-          <a:bodyPr wrap="square" lIns="0" tIns="0" rIns="0" bIns="0" rtlCol="0" anchor="ctr"/>
-          <a:lstStyle/>
-          <a:p>
-            <a:pPr algn="l" indent="0" marL="0">
-              <a:lnSpc>
-                <a:spcPct val="100000"/>
-              </a:lnSpc>
-              <a:buNone/>
-            </a:pPr>
-            <a:r>
-              <a:rPr lang="en-US" sz="900" dirty="0">
-                <a:solidFill>
-                  <a:srgbClr val="5B6068"/>
-                </a:solidFill>
-                <a:latin typeface="Calibri" pitchFamily="34" charset="0"/>
-                <a:ea typeface="Calibri" pitchFamily="34" charset="-122"/>
-                <a:cs typeface="Calibri" pitchFamily="34" charset="-120"/>
-              </a:rPr>
-              <a:t>responde  1</a:t>
-            </a:r>
-            <a:endParaRPr lang="en-US" sz="900" dirty="0"/>
-          </a:p>
-        </p:txBody>
-      </p:sp>
-      <p:sp>
-        <p:nvSpPr>
-          <p:cNvPr id="51" name="Shape 49"/>
-          <p:cNvSpPr/>
-          <p:nvPr/>
-        </p:nvSpPr>
-        <p:spPr>
-          <a:xfrm flipV="1">
-            <a:off x="8275320" y="3108960"/>
-            <a:ext cx="1371600" cy="731520"/>
-          </a:xfrm>
-          <a:prstGeom prst="line">
-            <a:avLst/>
-          </a:prstGeom>
-          <a:noFill/>
-          <a:ln w="12700">
-            <a:solidFill>
-              <a:srgbClr val="5B6068"/>
-            </a:solidFill>
-            <a:prstDash val="solid"/>
-            <a:tailEnd type="arrow"/>
-          </a:ln>
-        </p:spPr>
-      </p:sp>
-      <p:sp>
-        <p:nvSpPr>
-          <p:cNvPr id="52" name="Text 50"/>
-          <p:cNvSpPr/>
-          <p:nvPr/>
-        </p:nvSpPr>
-        <p:spPr>
-          <a:xfrm>
-            <a:off x="8275320" y="3246120"/>
-            <a:ext cx="914400" cy="182880"/>
-          </a:xfrm>
-          <a:prstGeom prst="rect">
-            <a:avLst/>
-          </a:prstGeom>
-          <a:solidFill>
-            <a:srgbClr val="F7F6F3"/>
-          </a:solidFill>
-          <a:ln/>
-        </p:spPr>
-        <p:txBody>
-          <a:bodyPr wrap="square" lIns="0" tIns="0" rIns="0" bIns="0" rtlCol="0" anchor="ctr"/>
-          <a:lstStyle/>
-          <a:p>
-            <a:pPr algn="ctr" indent="0" marL="0">
-              <a:lnSpc>
-                <a:spcPct val="100000"/>
-              </a:lnSpc>
-              <a:buNone/>
-            </a:pPr>
-            <a:r>
-              <a:rPr lang="en-US" sz="900" dirty="0">
-                <a:solidFill>
-                  <a:srgbClr val="5B6068"/>
-                </a:solidFill>
-                <a:latin typeface="Calibri" pitchFamily="34" charset="0"/>
-                <a:ea typeface="Calibri" pitchFamily="34" charset="-122"/>
-                <a:cs typeface="Calibri" pitchFamily="34" charset="-120"/>
-              </a:rPr>
-              <a:t>pertence a  1</a:t>
-            </a:r>
-            <a:endParaRPr lang="en-US" sz="900" dirty="0"/>
-          </a:p>
-        </p:txBody>
-      </p:sp>
-      <p:sp>
-        <p:nvSpPr>
-          <p:cNvPr id="53" name="Shape 51"/>
-          <p:cNvSpPr/>
-          <p:nvPr/>
-        </p:nvSpPr>
-        <p:spPr>
-          <a:xfrm>
-            <a:off x="8549640" y="4389120"/>
-            <a:ext cx="822960" cy="0"/>
-          </a:xfrm>
-          <a:prstGeom prst="line">
-            <a:avLst/>
-          </a:prstGeom>
-          <a:noFill/>
-          <a:ln w="12700">
-            <a:solidFill>
-              <a:srgbClr val="5B6068"/>
-            </a:solidFill>
-            <a:prstDash val="solid"/>
-            <a:tailEnd type="arrow"/>
-          </a:ln>
-        </p:spPr>
-      </p:sp>
-      <p:sp>
-        <p:nvSpPr>
-          <p:cNvPr id="54" name="Text 52"/>
-          <p:cNvSpPr/>
-          <p:nvPr/>
-        </p:nvSpPr>
-        <p:spPr>
-          <a:xfrm>
-            <a:off x="8567928" y="4114800"/>
-            <a:ext cx="786384" cy="182880"/>
-          </a:xfrm>
-          <a:prstGeom prst="rect">
-            <a:avLst/>
-          </a:prstGeom>
-          <a:solidFill>
-            <a:srgbClr val="F7F6F3"/>
-          </a:solidFill>
-          <a:ln/>
-        </p:spPr>
-        <p:txBody>
-          <a:bodyPr wrap="square" lIns="0" tIns="0" rIns="0" bIns="0" rtlCol="0" anchor="ctr"/>
-          <a:lstStyle/>
-          <a:p>
-            <a:pPr algn="ctr" indent="0" marL="0">
-              <a:lnSpc>
-                <a:spcPct val="100000"/>
-              </a:lnSpc>
-              <a:buNone/>
-            </a:pPr>
-            <a:r>
-              <a:rPr lang="en-US" sz="900" dirty="0">
-                <a:solidFill>
-                  <a:srgbClr val="5B6068"/>
-                </a:solidFill>
-                <a:latin typeface="Calibri" pitchFamily="34" charset="0"/>
-                <a:ea typeface="Calibri" pitchFamily="34" charset="-122"/>
-                <a:cs typeface="Calibri" pitchFamily="34" charset="-120"/>
-              </a:rPr>
-              <a:t>possui  1</a:t>
-            </a:r>
-            <a:endParaRPr lang="en-US" sz="900" dirty="0"/>
-          </a:p>
-        </p:txBody>
-      </p:sp>
-      <p:sp>
-        <p:nvSpPr>
-          <p:cNvPr id="55" name="Shape 53"/>
-          <p:cNvSpPr/>
-          <p:nvPr/>
-        </p:nvSpPr>
-        <p:spPr>
-          <a:xfrm>
-            <a:off x="4640580" y="5321808"/>
-            <a:ext cx="0" cy="667512"/>
-          </a:xfrm>
-          <a:prstGeom prst="line">
-            <a:avLst/>
-          </a:prstGeom>
-          <a:noFill/>
-          <a:ln w="12700">
-            <a:solidFill>
-              <a:srgbClr val="5B6068"/>
-            </a:solidFill>
-            <a:prstDash val="solid"/>
-          </a:ln>
-        </p:spPr>
-      </p:sp>
-      <p:sp>
-        <p:nvSpPr>
-          <p:cNvPr id="56" name="Shape 54"/>
-          <p:cNvSpPr/>
-          <p:nvPr/>
-        </p:nvSpPr>
-        <p:spPr>
-          <a:xfrm>
-            <a:off x="4640580" y="5989320"/>
-            <a:ext cx="411480" cy="0"/>
-          </a:xfrm>
-          <a:prstGeom prst="line">
-            <a:avLst/>
-          </a:prstGeom>
-          <a:noFill/>
-          <a:ln w="12700">
-            <a:solidFill>
-              <a:srgbClr val="5B6068"/>
-            </a:solidFill>
-            <a:prstDash val="solid"/>
-            <a:tailEnd type="arrow"/>
-          </a:ln>
-        </p:spPr>
-      </p:sp>
-      <p:sp>
-        <p:nvSpPr>
-          <p:cNvPr id="57" name="Text 55"/>
-          <p:cNvSpPr/>
-          <p:nvPr/>
-        </p:nvSpPr>
-        <p:spPr>
-          <a:xfrm>
-            <a:off x="3497580" y="5532120"/>
-            <a:ext cx="1078992" cy="182880"/>
-          </a:xfrm>
-          <a:prstGeom prst="rect">
-            <a:avLst/>
-          </a:prstGeom>
-          <a:solidFill>
-            <a:srgbClr val="F7F6F3"/>
-          </a:solidFill>
-          <a:ln/>
-        </p:spPr>
-        <p:txBody>
-          <a:bodyPr wrap="square" lIns="0" tIns="0" rIns="0" bIns="0" rtlCol="0" anchor="ctr"/>
-          <a:lstStyle/>
-          <a:p>
-            <a:pPr algn="r" indent="0" marL="0">
-              <a:lnSpc>
-                <a:spcPct val="100000"/>
-              </a:lnSpc>
-              <a:buNone/>
-            </a:pPr>
-            <a:r>
-              <a:rPr lang="en-US" sz="900" dirty="0">
-                <a:solidFill>
-                  <a:srgbClr val="5B6068"/>
-                </a:solidFill>
-                <a:latin typeface="Calibri" pitchFamily="34" charset="0"/>
-                <a:ea typeface="Calibri" pitchFamily="34" charset="-122"/>
-                <a:cs typeface="Calibri" pitchFamily="34" charset="-120"/>
-              </a:rPr>
-              <a:t>calculado por  1</a:t>
-            </a:r>
-            <a:endParaRPr lang="en-US" sz="900" dirty="0"/>
-          </a:p>
-        </p:txBody>
-      </p:sp>
-      <p:sp>
-        <p:nvSpPr>
-          <p:cNvPr id="58" name="Shape 56"/>
-          <p:cNvSpPr/>
-          <p:nvPr/>
-        </p:nvSpPr>
-        <p:spPr>
-          <a:xfrm>
-            <a:off x="7520940" y="5084064"/>
-            <a:ext cx="0" cy="905256"/>
-          </a:xfrm>
-          <a:prstGeom prst="line">
-            <a:avLst/>
-          </a:prstGeom>
-          <a:noFill/>
-          <a:ln w="12700">
-            <a:solidFill>
-              <a:srgbClr val="5B6068"/>
-            </a:solidFill>
-            <a:prstDash val="solid"/>
-          </a:ln>
-        </p:spPr>
-      </p:sp>
-      <p:sp>
-        <p:nvSpPr>
-          <p:cNvPr id="59" name="Shape 57"/>
-          <p:cNvSpPr/>
-          <p:nvPr/>
-        </p:nvSpPr>
-        <p:spPr>
-          <a:xfrm flipH="1">
-            <a:off x="7109460" y="5989320"/>
-            <a:ext cx="411480" cy="0"/>
-          </a:xfrm>
-          <a:prstGeom prst="line">
-            <a:avLst/>
-          </a:prstGeom>
-          <a:noFill/>
-          <a:ln w="12700">
-            <a:solidFill>
-              <a:srgbClr val="5B6068"/>
-            </a:solidFill>
-            <a:prstDash val="solid"/>
-            <a:tailEnd type="arrow"/>
-          </a:ln>
-        </p:spPr>
-      </p:sp>
-      <p:sp>
-        <p:nvSpPr>
-          <p:cNvPr id="60" name="Text 58"/>
-          <p:cNvSpPr/>
-          <p:nvPr/>
-        </p:nvSpPr>
-        <p:spPr>
-          <a:xfrm>
-            <a:off x="7575804" y="5532120"/>
-            <a:ext cx="1188720" cy="182880"/>
-          </a:xfrm>
-          <a:prstGeom prst="rect">
-            <a:avLst/>
-          </a:prstGeom>
-          <a:solidFill>
-            <a:srgbClr val="F7F6F3"/>
-          </a:solidFill>
-          <a:ln/>
-        </p:spPr>
-        <p:txBody>
-          <a:bodyPr wrap="square" lIns="0" tIns="0" rIns="0" bIns="0" rtlCol="0" anchor="ctr"/>
-          <a:lstStyle/>
-          <a:p>
-            <a:pPr algn="l" indent="0" marL="0">
-              <a:lnSpc>
-                <a:spcPct val="100000"/>
-              </a:lnSpc>
-              <a:buNone/>
-            </a:pPr>
-            <a:r>
-              <a:rPr lang="en-US" sz="900" dirty="0">
-                <a:solidFill>
-                  <a:srgbClr val="5B6068"/>
-                </a:solidFill>
-                <a:latin typeface="Calibri" pitchFamily="34" charset="0"/>
-                <a:ea typeface="Calibri" pitchFamily="34" charset="-122"/>
-                <a:cs typeface="Calibri" pitchFamily="34" charset="-120"/>
-              </a:rPr>
-              <a:t>classificada em  1</a:t>
-            </a:r>
-            <a:endParaRPr lang="en-US" sz="900" dirty="0"/>
-          </a:p>
-        </p:txBody>
-      </p:sp>
-      <p:sp>
-        <p:nvSpPr>
           <p:cNvPr id="61" name="Text 59"/>
           <p:cNvSpPr/>
           <p:nvPr/>
@@ -9462,6 +7442,30 @@
           </a:p>
         </p:txBody>
       </p:sp>
+      <p:pic>
+        <p:nvPicPr>
+          <p:cNvPr id="200" name="Diagrama de Classes Imagem"/>
+          <p:cNvPicPr>
+            <a:picLocks noChangeAspect="1"/>
+          </p:cNvPicPr>
+          <p:nvPr/>
+        </p:nvPicPr>
+        <p:blipFill>
+          <a:blip r:embed="rIdImgDiagrama"/>
+          <a:stretch>
+            <a:fillRect/>
+          </a:stretch>
+        </p:blipFill>
+        <p:spPr>
+          <a:xfrm>
+            <a:off x="2300000" y="1942523"/>
+            <a:ext cx="9592000" cy="4472953"/>
+          </a:xfrm>
+          <a:prstGeom prst="rect">
+            <a:avLst/>
+          </a:prstGeom>
+        </p:spPr>
+      </p:pic>
     </p:spTree>
   </p:cSld>
   <p:clrMapOvr>

</xml_diff>

<commit_message>
Deployed f7b7780 with MkDocs version: 1.5.3
</commit_message>
<xml_diff>
--- a/assets/apresentacao.pptx
+++ b/assets/apresentacao.pptx
@@ -6444,6 +6444,48 @@
       </p:sp>
       <p:sp>
         <p:nvSpPr>
+          <p:cNvPr id="901" name="Text 901"/>
+          <p:cNvSpPr/>
+          <p:nvPr/>
+        </p:nvSpPr>
+        <p:spPr>
+          <a:xfrm>
+            <a:off x="5669280" y="2148840"/>
+            <a:ext cx="2621128" cy="502920"/>
+          </a:xfrm>
+          <a:prstGeom prst="rect">
+            <a:avLst/>
+          </a:prstGeom>
+          <a:noFill/>
+          <a:ln/>
+        </p:spPr>
+        <p:txBody>
+          <a:bodyPr wrap="square" lIns="0" tIns="0" rIns="0" bIns="0" rtlCol="0" anchor="t"/>
+          <a:lstStyle/>
+          <a:p>
+            <a:pPr algn="l" indent="0" marL="0">
+              <a:lnSpc>
+                <a:spcPct val="110000"/>
+              </a:lnSpc>
+              <a:buNone/>
+            </a:pPr>
+            <a:r>
+              <a:rPr lang="en-US" sz="1200" dirty="0">
+                <a:solidFill>
+                  <a:srgbClr val="5B6068"/>
+                </a:solidFill>
+                <a:latin typeface="Calibri" pitchFamily="34" charset="0"/>
+                <a:ea typeface="Calibri" pitchFamily="34" charset="-122"/>
+                <a:cs typeface="Calibri" pitchFamily="34" charset="-120"/>
+              </a:rPr>
+              <a:t>AWS IAM, MFA, Grupos IAM</a:t>
+            </a:r>
+            <a:endParaRPr lang="en-US" sz="1200" dirty="0"/>
+          </a:p>
+        </p:txBody>
+      </p:sp>
+      <p:sp>
+        <p:nvSpPr>
           <p:cNvPr id="12" name="Shape 10"/>
           <p:cNvSpPr/>
           <p:nvPr/>
@@ -6551,6 +6593,48 @@
       </p:sp>
       <p:sp>
         <p:nvSpPr>
+          <p:cNvPr id="902" name="Text 902"/>
+          <p:cNvSpPr/>
+          <p:nvPr/>
+        </p:nvSpPr>
+        <p:spPr>
+          <a:xfrm>
+            <a:off x="8747608" y="2148840"/>
+            <a:ext cx="2621128" cy="502920"/>
+          </a:xfrm>
+          <a:prstGeom prst="rect">
+            <a:avLst/>
+          </a:prstGeom>
+          <a:noFill/>
+          <a:ln/>
+        </p:spPr>
+        <p:txBody>
+          <a:bodyPr wrap="square" lIns="0" tIns="0" rIns="0" bIns="0" rtlCol="0" anchor="t"/>
+          <a:lstStyle/>
+          <a:p>
+            <a:pPr algn="l" indent="0" marL="0">
+              <a:lnSpc>
+                <a:spcPct val="110000"/>
+              </a:lnSpc>
+              <a:buNone/>
+            </a:pPr>
+            <a:r>
+              <a:rPr lang="en-US" sz="1200" dirty="0">
+                <a:solidFill>
+                  <a:srgbClr val="5B6068"/>
+                </a:solidFill>
+                <a:latin typeface="Calibri" pitchFamily="34" charset="0"/>
+                <a:ea typeface="Calibri" pitchFamily="34" charset="-122"/>
+                <a:cs typeface="Calibri" pitchFamily="34" charset="-120"/>
+              </a:rPr>
+              <a:t>Security Groups (VPC)</a:t>
+            </a:r>
+            <a:endParaRPr lang="en-US" sz="1200" dirty="0"/>
+          </a:p>
+        </p:txBody>
+      </p:sp>
+      <p:sp>
+        <p:nvSpPr>
           <p:cNvPr id="15" name="Shape 13"/>
           <p:cNvSpPr/>
           <p:nvPr/>
@@ -6658,6 +6742,48 @@
       </p:sp>
       <p:sp>
         <p:nvSpPr>
+          <p:cNvPr id="903" name="Text 903"/>
+          <p:cNvSpPr/>
+          <p:nvPr/>
+        </p:nvSpPr>
+        <p:spPr>
+          <a:xfrm>
+            <a:off x="5669280" y="3721608"/>
+            <a:ext cx="2621128" cy="502920"/>
+          </a:xfrm>
+          <a:prstGeom prst="rect">
+            <a:avLst/>
+          </a:prstGeom>
+          <a:noFill/>
+          <a:ln/>
+        </p:spPr>
+        <p:txBody>
+          <a:bodyPr wrap="square" lIns="0" tIns="0" rIns="0" bIns="0" rtlCol="0" anchor="t"/>
+          <a:lstStyle/>
+          <a:p>
+            <a:pPr algn="l" indent="0" marL="0">
+              <a:lnSpc>
+                <a:spcPct val="110000"/>
+              </a:lnSpc>
+              <a:buNone/>
+            </a:pPr>
+            <a:r>
+              <a:rPr lang="en-US" sz="1200" dirty="0">
+                <a:solidFill>
+                  <a:srgbClr val="5B6068"/>
+                </a:solidFill>
+                <a:latin typeface="Calibri" pitchFamily="34" charset="0"/>
+                <a:ea typeface="Calibri" pitchFamily="34" charset="-122"/>
+                <a:cs typeface="Calibri" pitchFamily="34" charset="-120"/>
+              </a:rPr>
+              <a:t>AWS KMS, ACM, RDS/S3 Encryption</a:t>
+            </a:r>
+            <a:endParaRPr lang="en-US" sz="1200" dirty="0"/>
+          </a:p>
+        </p:txBody>
+      </p:sp>
+      <p:sp>
+        <p:nvSpPr>
           <p:cNvPr id="18" name="Shape 16"/>
           <p:cNvSpPr/>
           <p:nvPr/>
@@ -6799,7 +6925,7 @@
                 <a:ea typeface="Calibri" pitchFamily="34" charset="-122"/>
                 <a:cs typeface="Calibri" pitchFamily="34" charset="-120"/>
               </a:rPr>
-              <a:t>Desmembrado de um pacote único.</a:t>
+              <a:t>AWS Secrets Manager</a:t>
             </a:r>
             <a:endParaRPr lang="en-US" sz="1200" dirty="0"/>
           </a:p>
@@ -6948,7 +7074,7 @@
                 <a:ea typeface="Calibri" pitchFamily="34" charset="-122"/>
                 <a:cs typeface="Calibri" pitchFamily="34" charset="-120"/>
               </a:rPr>
-              <a:t>Desmembrado de um pacote único.</a:t>
+              <a:t>AWS CloudTrail</a:t>
             </a:r>
             <a:endParaRPr lang="en-US" sz="1200" dirty="0"/>
           </a:p>
@@ -7097,7 +7223,7 @@
                 <a:ea typeface="Calibri" pitchFamily="34" charset="-122"/>
                 <a:cs typeface="Calibri" pitchFamily="34" charset="-120"/>
               </a:rPr>
-              <a:t>Antes evolução futura, agora pacote ativo com CloudWatch.</a:t>
+              <a:t>Amazon CloudWatch (Logs, Alarms, Dashboards)</a:t>
             </a:r>
             <a:endParaRPr lang="en-US" sz="1200" dirty="0"/>
           </a:p>

</xml_diff>